<commit_message>
docs: refine hw2 report and presentation wording
</commit_message>
<xml_diff>
--- a/hw2/presentation.pptx
+++ b/hw2/presentation.pptx
@@ -2,29 +2,29 @@
 <file path=ppt/presentation.xml><?xml version="1.0" encoding="utf-8"?>
 <p:presentation xmlns:p="http://schemas.openxmlformats.org/presentationml/2006/main">
   <p:sldMasterIdLst>
-    <p:sldMasterId xmlns:r="http://schemas.openxmlformats.org/officeDocument/2006/relationships" id="2147483648" r:id="R56a00c65e39a4346"/>
+    <p:sldMasterId xmlns:r="http://schemas.openxmlformats.org/officeDocument/2006/relationships" id="2147483648" r:id="Rbf3eba4b929a4956"/>
   </p:sldMasterIdLst>
   <p:notesMasterIdLst>
-    <p:notesMasterId xmlns:r="http://schemas.openxmlformats.org/officeDocument/2006/relationships" r:id="R28b8e41c09624905"/>
+    <p:notesMasterId xmlns:r="http://schemas.openxmlformats.org/officeDocument/2006/relationships" r:id="R6193f3252e604af6"/>
   </p:notesMasterIdLst>
   <p:sldIdLst>
-    <p:sldId xmlns:r="http://schemas.openxmlformats.org/officeDocument/2006/relationships" id="256" r:id="R29f6bb53660a4bf7"/>
-    <p:sldId xmlns:r="http://schemas.openxmlformats.org/officeDocument/2006/relationships" id="257" r:id="R2b668deae00d43e9"/>
-    <p:sldId xmlns:r="http://schemas.openxmlformats.org/officeDocument/2006/relationships" id="258" r:id="R4a559b588d944bf5"/>
-    <p:sldId xmlns:r="http://schemas.openxmlformats.org/officeDocument/2006/relationships" id="259" r:id="Rd19aa6d9052f48b5"/>
-    <p:sldId xmlns:r="http://schemas.openxmlformats.org/officeDocument/2006/relationships" id="260" r:id="R54ef134dd2f243ed"/>
-    <p:sldId xmlns:r="http://schemas.openxmlformats.org/officeDocument/2006/relationships" id="261" r:id="Rc0e312cae8a84624"/>
-    <p:sldId xmlns:r="http://schemas.openxmlformats.org/officeDocument/2006/relationships" id="262" r:id="R98d4c0198a5e46a9"/>
-    <p:sldId xmlns:r="http://schemas.openxmlformats.org/officeDocument/2006/relationships" id="263" r:id="Rb462501ace1a4521"/>
-    <p:sldId xmlns:r="http://schemas.openxmlformats.org/officeDocument/2006/relationships" id="264" r:id="R485ac388f5034dbe"/>
-    <p:sldId xmlns:r="http://schemas.openxmlformats.org/officeDocument/2006/relationships" id="265" r:id="R8eb689dee4d04353"/>
-    <p:sldId xmlns:r="http://schemas.openxmlformats.org/officeDocument/2006/relationships" id="266" r:id="Rc3cf390bb0ce4b44"/>
-    <p:sldId xmlns:r="http://schemas.openxmlformats.org/officeDocument/2006/relationships" id="267" r:id="Rf017846c38484286"/>
-    <p:sldId xmlns:r="http://schemas.openxmlformats.org/officeDocument/2006/relationships" id="268" r:id="R723c5fb607b6425e"/>
-    <p:sldId xmlns:r="http://schemas.openxmlformats.org/officeDocument/2006/relationships" id="269" r:id="Rbf170183366e4e62"/>
-    <p:sldId xmlns:r="http://schemas.openxmlformats.org/officeDocument/2006/relationships" id="270" r:id="R520cb42da5f54781"/>
-    <p:sldId xmlns:r="http://schemas.openxmlformats.org/officeDocument/2006/relationships" id="271" r:id="Rf89daba1ce5f468a"/>
-    <p:sldId xmlns:r="http://schemas.openxmlformats.org/officeDocument/2006/relationships" id="272" r:id="R53abb6c1121a44f3"/>
+    <p:sldId xmlns:r="http://schemas.openxmlformats.org/officeDocument/2006/relationships" id="256" r:id="R71cdb5e42b684227"/>
+    <p:sldId xmlns:r="http://schemas.openxmlformats.org/officeDocument/2006/relationships" id="257" r:id="R285ff6e7e3ce4892"/>
+    <p:sldId xmlns:r="http://schemas.openxmlformats.org/officeDocument/2006/relationships" id="258" r:id="R57c0bba8afe843da"/>
+    <p:sldId xmlns:r="http://schemas.openxmlformats.org/officeDocument/2006/relationships" id="259" r:id="R00d1e024342f4e78"/>
+    <p:sldId xmlns:r="http://schemas.openxmlformats.org/officeDocument/2006/relationships" id="260" r:id="R90030033598b4bee"/>
+    <p:sldId xmlns:r="http://schemas.openxmlformats.org/officeDocument/2006/relationships" id="261" r:id="R77f7a20c9cdc4337"/>
+    <p:sldId xmlns:r="http://schemas.openxmlformats.org/officeDocument/2006/relationships" id="262" r:id="Re671cad1b9724d71"/>
+    <p:sldId xmlns:r="http://schemas.openxmlformats.org/officeDocument/2006/relationships" id="263" r:id="R4f7772e4efae4d0b"/>
+    <p:sldId xmlns:r="http://schemas.openxmlformats.org/officeDocument/2006/relationships" id="264" r:id="Rc578670b0f274b05"/>
+    <p:sldId xmlns:r="http://schemas.openxmlformats.org/officeDocument/2006/relationships" id="265" r:id="R946158fdaab14661"/>
+    <p:sldId xmlns:r="http://schemas.openxmlformats.org/officeDocument/2006/relationships" id="266" r:id="R17f638db726d470c"/>
+    <p:sldId xmlns:r="http://schemas.openxmlformats.org/officeDocument/2006/relationships" id="267" r:id="R8f4673a57f074712"/>
+    <p:sldId xmlns:r="http://schemas.openxmlformats.org/officeDocument/2006/relationships" id="268" r:id="Rd75d8783e8bc4ad2"/>
+    <p:sldId xmlns:r="http://schemas.openxmlformats.org/officeDocument/2006/relationships" id="269" r:id="R2ea7338a54c940e5"/>
+    <p:sldId xmlns:r="http://schemas.openxmlformats.org/officeDocument/2006/relationships" id="270" r:id="Rdbb4577dd1454ee3"/>
+    <p:sldId xmlns:r="http://schemas.openxmlformats.org/officeDocument/2006/relationships" id="271" r:id="Re669bc5758ac42da"/>
+    <p:sldId xmlns:r="http://schemas.openxmlformats.org/officeDocument/2006/relationships" id="272" r:id="R928d911ca6eb446f"/>
   </p:sldIdLst>
   <p:sldSz cx="12192000" cy="6858000"/>
   <p:notesSz cx="6858000" cy="9144000"/>
@@ -1880,7 +1880,7 @@
           <p:cNvPr id="3" name="Title">
             <a:extLst xmlns:a="http://schemas.openxmlformats.org/drawingml/2006/main">
               <a:ext uri="{FF2B5EF4-FFF2-40B4-BE49-F238E27FC236}">
-                <a16:creationId xmlns:a16="http://schemas.microsoft.com/office/drawing/2014/main" id="{4773C23A-8257-4B09-96EE-87C9F33EEDD3}"/>
+                <a16:creationId xmlns:a16="http://schemas.microsoft.com/office/drawing/2014/main" id="{4744806F-AF4A-441B-9C2E-FF238870FA88}"/>
               </a:ext>
             </a:extLst>
           </p:cNvPr>
@@ -2037,7 +2037,7 @@
           <p:cNvPr id="2" name="Subtitle">
             <a:extLst xmlns:a="http://schemas.openxmlformats.org/drawingml/2006/main">
               <a:ext uri="{FF2B5EF4-FFF2-40B4-BE49-F238E27FC236}">
-                <a16:creationId xmlns:a16="http://schemas.microsoft.com/office/drawing/2014/main" id="{3FFF9268-4F78-4AB8-AAEE-F6A6BBE8E93F}"/>
+                <a16:creationId xmlns:a16="http://schemas.microsoft.com/office/drawing/2014/main" id="{81F726F6-9321-4010-A72D-7FA5B3CDC403}"/>
               </a:ext>
             </a:extLst>
           </p:cNvPr>
@@ -2211,7 +2211,7 @@
           <p:cNvPr id="2" name="Section title">
             <a:extLst xmlns:a="http://schemas.openxmlformats.org/drawingml/2006/main">
               <a:ext uri="{FF2B5EF4-FFF2-40B4-BE49-F238E27FC236}">
-                <a16:creationId xmlns:a16="http://schemas.microsoft.com/office/drawing/2014/main" id="{FB324BC2-6423-4CE7-B782-3B7D143A59D8}"/>
+                <a16:creationId xmlns:a16="http://schemas.microsoft.com/office/drawing/2014/main" id="{9A389D2E-0476-426B-92AF-768F913AC204}"/>
               </a:ext>
             </a:extLst>
           </p:cNvPr>
@@ -2385,7 +2385,7 @@
           <p:cNvPr id="3" name="Title">
             <a:extLst xmlns:a="http://schemas.openxmlformats.org/drawingml/2006/main">
               <a:ext uri="{FF2B5EF4-FFF2-40B4-BE49-F238E27FC236}">
-                <a16:creationId xmlns:a16="http://schemas.microsoft.com/office/drawing/2014/main" id="{F188C42D-874C-46FA-BC09-2B9C3ACC5B29}"/>
+                <a16:creationId xmlns:a16="http://schemas.microsoft.com/office/drawing/2014/main" id="{92483309-547D-4F6A-A753-2CD653345597}"/>
               </a:ext>
             </a:extLst>
           </p:cNvPr>
@@ -2542,7 +2542,7 @@
           <p:cNvPr id="2" name="Body">
             <a:extLst xmlns:a="http://schemas.openxmlformats.org/drawingml/2006/main">
               <a:ext uri="{FF2B5EF4-FFF2-40B4-BE49-F238E27FC236}">
-                <a16:creationId xmlns:a16="http://schemas.microsoft.com/office/drawing/2014/main" id="{B79F99E9-EAE0-4907-9D70-F62A0935BBD3}"/>
+                <a16:creationId xmlns:a16="http://schemas.microsoft.com/office/drawing/2014/main" id="{141E33F3-D142-41B3-91E9-8FFB44172F5E}"/>
               </a:ext>
             </a:extLst>
           </p:cNvPr>
@@ -2716,7 +2716,7 @@
           <p:cNvPr id="4" name="Title">
             <a:extLst xmlns:a="http://schemas.openxmlformats.org/drawingml/2006/main">
               <a:ext uri="{FF2B5EF4-FFF2-40B4-BE49-F238E27FC236}">
-                <a16:creationId xmlns:a16="http://schemas.microsoft.com/office/drawing/2014/main" id="{57ED16EB-3327-467D-A547-DD92FBD6F78B}"/>
+                <a16:creationId xmlns:a16="http://schemas.microsoft.com/office/drawing/2014/main" id="{6D8676AF-4E9B-4A90-AA13-4D79946A46A0}"/>
               </a:ext>
             </a:extLst>
           </p:cNvPr>
@@ -2873,7 +2873,7 @@
           <p:cNvPr id="2" name="Left column">
             <a:extLst xmlns:a="http://schemas.openxmlformats.org/drawingml/2006/main">
               <a:ext uri="{FF2B5EF4-FFF2-40B4-BE49-F238E27FC236}">
-                <a16:creationId xmlns:a16="http://schemas.microsoft.com/office/drawing/2014/main" id="{5C88DDA8-F8BD-420D-8D76-4AD16C28C207}"/>
+                <a16:creationId xmlns:a16="http://schemas.microsoft.com/office/drawing/2014/main" id="{A87AD001-5DCC-4643-ADBF-5D1C5143FE7B}"/>
               </a:ext>
             </a:extLst>
           </p:cNvPr>
@@ -3030,7 +3030,7 @@
           <p:cNvPr id="3" name="Right column">
             <a:extLst xmlns:a="http://schemas.openxmlformats.org/drawingml/2006/main">
               <a:ext uri="{FF2B5EF4-FFF2-40B4-BE49-F238E27FC236}">
-                <a16:creationId xmlns:a16="http://schemas.microsoft.com/office/drawing/2014/main" id="{15D4D7C6-D6E3-4BD1-AF6E-B7F63484A3AA}"/>
+                <a16:creationId xmlns:a16="http://schemas.microsoft.com/office/drawing/2014/main" id="{1F2E10D5-847F-4F2C-AE94-583BFB62768D}"/>
               </a:ext>
             </a:extLst>
           </p:cNvPr>
@@ -3204,7 +3204,7 @@
           <p:cNvPr id="3" name="Title">
             <a:extLst xmlns:a="http://schemas.openxmlformats.org/drawingml/2006/main">
               <a:ext uri="{FF2B5EF4-FFF2-40B4-BE49-F238E27FC236}">
-                <a16:creationId xmlns:a16="http://schemas.microsoft.com/office/drawing/2014/main" id="{AB8CBEA1-345D-409E-8C03-6C65E284E0FF}"/>
+                <a16:creationId xmlns:a16="http://schemas.microsoft.com/office/drawing/2014/main" id="{BBAC1826-46FD-4BFE-A1BA-171C50E11C61}"/>
               </a:ext>
             </a:extLst>
           </p:cNvPr>
@@ -3361,7 +3361,7 @@
           <p:cNvPr id="2" name="Left column">
             <a:extLst xmlns:a="http://schemas.openxmlformats.org/drawingml/2006/main">
               <a:ext uri="{FF2B5EF4-FFF2-40B4-BE49-F238E27FC236}">
-                <a16:creationId xmlns:a16="http://schemas.microsoft.com/office/drawing/2014/main" id="{4E07DF1A-EA7D-4085-A4C2-68EBE7683734}"/>
+                <a16:creationId xmlns:a16="http://schemas.microsoft.com/office/drawing/2014/main" id="{E94ED05E-2E72-411E-A94E-23E88B8A2A52}"/>
               </a:ext>
             </a:extLst>
           </p:cNvPr>
@@ -3556,12 +3556,12 @@
   </p:cSld>
   <p:clrMap bg1="lt1" tx1="dk1" bg2="lt2" tx2="dk2" accent1="accent1" accent2="accent2" accent3="accent3" accent4="accent4" accent5="accent5" accent6="accent6" hlink="hlink" folHlink="folHlink"/>
   <p:sldLayoutIdLst>
-    <p:sldLayoutId xmlns:r="http://schemas.openxmlformats.org/officeDocument/2006/relationships" id="2147483649" r:id="R2d23c2febed64401"/>
-    <p:sldLayoutId xmlns:r="http://schemas.openxmlformats.org/officeDocument/2006/relationships" id="2147483650" r:id="R351e33f47f9c43d1"/>
-    <p:sldLayoutId xmlns:r="http://schemas.openxmlformats.org/officeDocument/2006/relationships" id="2147483651" r:id="R9d77778771264757"/>
-    <p:sldLayoutId xmlns:r="http://schemas.openxmlformats.org/officeDocument/2006/relationships" id="2147483652" r:id="R36a05fcff700410f"/>
-    <p:sldLayoutId xmlns:r="http://schemas.openxmlformats.org/officeDocument/2006/relationships" id="2147483653" r:id="Re7cb5733151742e9"/>
-    <p:sldLayoutId xmlns:r="http://schemas.openxmlformats.org/officeDocument/2006/relationships" id="2147483654" r:id="R2186ebb39c5e47eb"/>
+    <p:sldLayoutId xmlns:r="http://schemas.openxmlformats.org/officeDocument/2006/relationships" id="2147483649" r:id="R6effe43e149942c8"/>
+    <p:sldLayoutId xmlns:r="http://schemas.openxmlformats.org/officeDocument/2006/relationships" id="2147483650" r:id="R24dfba68b2894b7e"/>
+    <p:sldLayoutId xmlns:r="http://schemas.openxmlformats.org/officeDocument/2006/relationships" id="2147483651" r:id="R66a6da4be3214c01"/>
+    <p:sldLayoutId xmlns:r="http://schemas.openxmlformats.org/officeDocument/2006/relationships" id="2147483652" r:id="R42cd981fe4014195"/>
+    <p:sldLayoutId xmlns:r="http://schemas.openxmlformats.org/officeDocument/2006/relationships" id="2147483653" r:id="Re2266960114d4a69"/>
+    <p:sldLayoutId xmlns:r="http://schemas.openxmlformats.org/officeDocument/2006/relationships" id="2147483654" r:id="R02a370ffeb0040bb"/>
   </p:sldLayoutIdLst>
   <p:txStyles>
     <p:titleStyle>
@@ -12622,7 +12622,7 @@
           <p:cNvPr id="4" name="">
             <a:extLst xmlns:a="http://schemas.openxmlformats.org/drawingml/2006/main">
               <a:ext uri="{FF2B5EF4-FFF2-40B4-BE49-F238E27FC236}">
-                <a16:creationId xmlns:a16="http://schemas.microsoft.com/office/drawing/2014/main" id="{6D278607-A50B-4015-ADA6-77DDCE727F98}"/>
+                <a16:creationId xmlns:a16="http://schemas.microsoft.com/office/drawing/2014/main" id="{C58EA832-48CC-4F1B-8D66-9D19EBFF5EEB}"/>
               </a:ext>
             </a:extLst>
           </p:cNvPr>
@@ -12721,7 +12721,7 @@
           <p:cNvPr id="2" name="">
             <a:extLst xmlns:a="http://schemas.openxmlformats.org/drawingml/2006/main">
               <a:ext uri="{FF2B5EF4-FFF2-40B4-BE49-F238E27FC236}">
-                <a16:creationId xmlns:a16="http://schemas.microsoft.com/office/drawing/2014/main" id="{4BE1471E-EA88-489B-97B6-D217567BEFD3}"/>
+                <a16:creationId xmlns:a16="http://schemas.microsoft.com/office/drawing/2014/main" id="{894A2401-AD04-4A00-A112-3363EE3AF4FF}"/>
               </a:ext>
             </a:extLst>
           </p:cNvPr>
@@ -12804,7 +12804,7 @@
           <p:cNvPr id="3" name="">
             <a:extLst xmlns:a="http://schemas.openxmlformats.org/drawingml/2006/main">
               <a:ext uri="{FF2B5EF4-FFF2-40B4-BE49-F238E27FC236}">
-                <a16:creationId xmlns:a16="http://schemas.microsoft.com/office/drawing/2014/main" id="{170AC506-694C-4107-A88D-9DCB8B7CFA1B}"/>
+                <a16:creationId xmlns:a16="http://schemas.microsoft.com/office/drawing/2014/main" id="{FA5BA63E-3EB4-4237-88B1-844F06862803}"/>
               </a:ext>
             </a:extLst>
           </p:cNvPr>
@@ -12874,7 +12874,7 @@
     </p:spTree>
     <p:extLst>
       <p:ext uri="{BB962C8B-B14F-4D97-AF65-F5344CB8AC3E}">
-        <p14:creationId xmlns:p14="http://schemas.microsoft.com/office/powerpoint/2010/main" val="76991775"/>
+        <p14:creationId xmlns:p14="http://schemas.microsoft.com/office/powerpoint/2010/main" val="1004754032"/>
       </p:ext>
     </p:extLst>
   </p:cSld>
@@ -12905,7 +12905,7 @@
           <p:cNvPr id="7" name="">
             <a:extLst xmlns:a="http://schemas.openxmlformats.org/drawingml/2006/main">
               <a:ext uri="{FF2B5EF4-FFF2-40B4-BE49-F238E27FC236}">
-                <a16:creationId xmlns:a16="http://schemas.microsoft.com/office/drawing/2014/main" id="{37E4C6FB-0E8B-49AB-9851-5A258C7763D2}"/>
+                <a16:creationId xmlns:a16="http://schemas.microsoft.com/office/drawing/2014/main" id="{1F2CBB94-4B32-4D04-BC7B-B2CADEC6E22C}"/>
               </a:ext>
             </a:extLst>
           </p:cNvPr>
@@ -12977,7 +12977,7 @@
           <p:cNvPr id="2" name="">
             <a:extLst xmlns:a="http://schemas.openxmlformats.org/drawingml/2006/main">
               <a:ext uri="{FF2B5EF4-FFF2-40B4-BE49-F238E27FC236}">
-                <a16:creationId xmlns:a16="http://schemas.microsoft.com/office/drawing/2014/main" id="{58A9A790-58C9-40A0-8B00-D1C1AABF1BAB}"/>
+                <a16:creationId xmlns:a16="http://schemas.microsoft.com/office/drawing/2014/main" id="{F4B94260-C92E-4B2A-B936-22FA29EF5343}"/>
               </a:ext>
             </a:extLst>
           </p:cNvPr>
@@ -13049,7 +13049,7 @@
           <p:cNvPr id="3" name="">
             <a:extLst xmlns:a="http://schemas.openxmlformats.org/drawingml/2006/main">
               <a:ext uri="{FF2B5EF4-FFF2-40B4-BE49-F238E27FC236}">
-                <a16:creationId xmlns:a16="http://schemas.microsoft.com/office/drawing/2014/main" id="{C3B57541-B6C6-48C5-BE08-5782912AE309}"/>
+                <a16:creationId xmlns:a16="http://schemas.microsoft.com/office/drawing/2014/main" id="{AE63276B-769D-4EC8-8E45-C90C45142B1F}"/>
               </a:ext>
             </a:extLst>
           </p:cNvPr>
@@ -13148,7 +13148,7 @@
           <p:cNvPr id="4" name="">
             <a:extLst xmlns:a="http://schemas.openxmlformats.org/drawingml/2006/main">
               <a:ext uri="{FF2B5EF4-FFF2-40B4-BE49-F238E27FC236}">
-                <a16:creationId xmlns:a16="http://schemas.microsoft.com/office/drawing/2014/main" id="{19851D5F-4DF1-44F7-859A-5BA6EA0C76AD}"/>
+                <a16:creationId xmlns:a16="http://schemas.microsoft.com/office/drawing/2014/main" id="{BBC33DFF-34B8-478E-9FFF-EDE34866F266}"/>
               </a:ext>
             </a:extLst>
           </p:cNvPr>
@@ -13471,7 +13471,7 @@
           <p:cNvPr id="5" name="">
             <a:extLst xmlns:a="http://schemas.openxmlformats.org/drawingml/2006/main">
               <a:ext uri="{FF2B5EF4-FFF2-40B4-BE49-F238E27FC236}">
-                <a16:creationId xmlns:a16="http://schemas.microsoft.com/office/drawing/2014/main" id="{E042727C-B37F-473F-93AE-DE85832FD46C}"/>
+                <a16:creationId xmlns:a16="http://schemas.microsoft.com/office/drawing/2014/main" id="{734B25EB-9353-4F0B-8FE2-B4B4354A92BF}"/>
               </a:ext>
             </a:extLst>
           </p:cNvPr>
@@ -13609,7 +13609,7 @@
           <p:cNvPr id="6" name="Chart">
             <a:extLst xmlns:a="http://schemas.openxmlformats.org/drawingml/2006/main">
               <a:ext uri="{FF2B5EF4-FFF2-40B4-BE49-F238E27FC236}">
-                <a16:creationId xmlns:a16="http://schemas.microsoft.com/office/drawing/2014/main" id="{EC4AA81E-19A7-4586-9A41-DEE457980204}"/>
+                <a16:creationId xmlns:a16="http://schemas.microsoft.com/office/drawing/2014/main" id="{39956A87-3072-4D76-A874-8DFEDD36E2AF}"/>
               </a:ext>
             </a:extLst>
           </p:cNvPr>
@@ -13622,14 +13622,14 @@
         </p:xfrm>
         <a:graphic xmlns:a="http://schemas.openxmlformats.org/drawingml/2006/main">
           <a:graphicData uri="http://schemas.openxmlformats.org/drawingml/2006/chart">
-            <c:chart xmlns:r="http://schemas.openxmlformats.org/officeDocument/2006/relationships" xmlns:c="http://schemas.openxmlformats.org/drawingml/2006/chart" r:id="Rf42f8cf84f7240dd"/>
+            <c:chart xmlns:r="http://schemas.openxmlformats.org/officeDocument/2006/relationships" xmlns:c="http://schemas.openxmlformats.org/drawingml/2006/chart" r:id="R17336b23838f4647"/>
           </a:graphicData>
         </a:graphic>
       </p:graphicFrame>
     </p:spTree>
     <p:extLst>
       <p:ext uri="{BB962C8B-B14F-4D97-AF65-F5344CB8AC3E}">
-        <p14:creationId xmlns:p14="http://schemas.microsoft.com/office/powerpoint/2010/main" val="2013189792"/>
+        <p14:creationId xmlns:p14="http://schemas.microsoft.com/office/powerpoint/2010/main" val="1897504149"/>
       </p:ext>
     </p:extLst>
   </p:cSld>
@@ -13660,7 +13660,7 @@
           <p:cNvPr id="6" name="">
             <a:extLst xmlns:a="http://schemas.openxmlformats.org/drawingml/2006/main">
               <a:ext uri="{FF2B5EF4-FFF2-40B4-BE49-F238E27FC236}">
-                <a16:creationId xmlns:a16="http://schemas.microsoft.com/office/drawing/2014/main" id="{73CC2A77-1B56-49FB-B35B-E8B8A7CC60F3}"/>
+                <a16:creationId xmlns:a16="http://schemas.microsoft.com/office/drawing/2014/main" id="{0CE751FD-40A9-4912-89DC-5D005323EB13}"/>
               </a:ext>
             </a:extLst>
           </p:cNvPr>
@@ -13732,7 +13732,7 @@
           <p:cNvPr id="2" name="">
             <a:extLst xmlns:a="http://schemas.openxmlformats.org/drawingml/2006/main">
               <a:ext uri="{FF2B5EF4-FFF2-40B4-BE49-F238E27FC236}">
-                <a16:creationId xmlns:a16="http://schemas.microsoft.com/office/drawing/2014/main" id="{C33DC47D-DAD2-4347-9DE9-158A5B0ACE3F}"/>
+                <a16:creationId xmlns:a16="http://schemas.microsoft.com/office/drawing/2014/main" id="{C558DB6E-9386-4D17-A569-1D7661DA138A}"/>
               </a:ext>
             </a:extLst>
           </p:cNvPr>
@@ -13804,7 +13804,7 @@
           <p:cNvPr id="3" name="">
             <a:extLst xmlns:a="http://schemas.openxmlformats.org/drawingml/2006/main">
               <a:ext uri="{FF2B5EF4-FFF2-40B4-BE49-F238E27FC236}">
-                <a16:creationId xmlns:a16="http://schemas.microsoft.com/office/drawing/2014/main" id="{D75B142C-814B-416A-B02E-D7EA2EF4CF37}"/>
+                <a16:creationId xmlns:a16="http://schemas.microsoft.com/office/drawing/2014/main" id="{4E6C35AB-812F-47F1-8CB2-41EA388812EA}"/>
               </a:ext>
             </a:extLst>
           </p:cNvPr>
@@ -13876,7 +13876,7 @@
           <p:cNvPr id="4" name="Chart">
             <a:extLst xmlns:a="http://schemas.openxmlformats.org/drawingml/2006/main">
               <a:ext uri="{FF2B5EF4-FFF2-40B4-BE49-F238E27FC236}">
-                <a16:creationId xmlns:a16="http://schemas.microsoft.com/office/drawing/2014/main" id="{77101822-F26D-4DB7-8CDA-11272CC01E96}"/>
+                <a16:creationId xmlns:a16="http://schemas.microsoft.com/office/drawing/2014/main" id="{634F97FE-602E-4605-BA48-3314D76EADD8}"/>
               </a:ext>
             </a:extLst>
           </p:cNvPr>
@@ -13889,7 +13889,7 @@
         </p:xfrm>
         <a:graphic xmlns:a="http://schemas.openxmlformats.org/drawingml/2006/main">
           <a:graphicData uri="http://schemas.openxmlformats.org/drawingml/2006/chart">
-            <c:chart xmlns:r="http://schemas.openxmlformats.org/officeDocument/2006/relationships" xmlns:c="http://schemas.openxmlformats.org/drawingml/2006/chart" r:id="R895756bcf89147ac"/>
+            <c:chart xmlns:r="http://schemas.openxmlformats.org/officeDocument/2006/relationships" xmlns:c="http://schemas.openxmlformats.org/drawingml/2006/chart" r:id="R5dd26a82b6814a55"/>
           </a:graphicData>
         </a:graphic>
       </p:graphicFrame>
@@ -13898,7 +13898,7 @@
           <p:cNvPr id="5" name="">
             <a:extLst xmlns:a="http://schemas.openxmlformats.org/drawingml/2006/main">
               <a:ext uri="{FF2B5EF4-FFF2-40B4-BE49-F238E27FC236}">
-                <a16:creationId xmlns:a16="http://schemas.microsoft.com/office/drawing/2014/main" id="{B0AAD9A6-6362-476B-846A-E67793AA1071}"/>
+                <a16:creationId xmlns:a16="http://schemas.microsoft.com/office/drawing/2014/main" id="{98A87552-F0E4-4527-BCA7-09B1AD6033DA}"/>
               </a:ext>
             </a:extLst>
           </p:cNvPr>
@@ -14023,7 +14023,7 @@
     </p:spTree>
     <p:extLst>
       <p:ext uri="{BB962C8B-B14F-4D97-AF65-F5344CB8AC3E}">
-        <p14:creationId xmlns:p14="http://schemas.microsoft.com/office/powerpoint/2010/main" val="1454032631"/>
+        <p14:creationId xmlns:p14="http://schemas.microsoft.com/office/powerpoint/2010/main" val="1930981285"/>
       </p:ext>
     </p:extLst>
   </p:cSld>
@@ -14054,7 +14054,7 @@
           <p:cNvPr id="7" name="">
             <a:extLst xmlns:a="http://schemas.openxmlformats.org/drawingml/2006/main">
               <a:ext uri="{FF2B5EF4-FFF2-40B4-BE49-F238E27FC236}">
-                <a16:creationId xmlns:a16="http://schemas.microsoft.com/office/drawing/2014/main" id="{6D65CE9F-8186-4405-8F1F-882D81597EA6}"/>
+                <a16:creationId xmlns:a16="http://schemas.microsoft.com/office/drawing/2014/main" id="{635172C1-3342-492B-BC12-E2B715696DF1}"/>
               </a:ext>
             </a:extLst>
           </p:cNvPr>
@@ -14126,7 +14126,7 @@
           <p:cNvPr id="2" name="">
             <a:extLst xmlns:a="http://schemas.openxmlformats.org/drawingml/2006/main">
               <a:ext uri="{FF2B5EF4-FFF2-40B4-BE49-F238E27FC236}">
-                <a16:creationId xmlns:a16="http://schemas.microsoft.com/office/drawing/2014/main" id="{A958C1CD-6863-4FD3-8513-9ABFDE005538}"/>
+                <a16:creationId xmlns:a16="http://schemas.microsoft.com/office/drawing/2014/main" id="{9A198DB3-7CA6-4C17-B34D-AE06B74B21C4}"/>
               </a:ext>
             </a:extLst>
           </p:cNvPr>
@@ -14198,7 +14198,7 @@
           <p:cNvPr id="3" name="">
             <a:extLst xmlns:a="http://schemas.openxmlformats.org/drawingml/2006/main">
               <a:ext uri="{FF2B5EF4-FFF2-40B4-BE49-F238E27FC236}">
-                <a16:creationId xmlns:a16="http://schemas.microsoft.com/office/drawing/2014/main" id="{8F02FDEB-AC18-406D-AB26-16BA0B08E5FA}"/>
+                <a16:creationId xmlns:a16="http://schemas.microsoft.com/office/drawing/2014/main" id="{74C0FC99-54D4-4713-8F20-9D69B5487B06}"/>
               </a:ext>
             </a:extLst>
           </p:cNvPr>
@@ -14270,7 +14270,7 @@
           <p:cNvPr id="4" name="">
             <a:extLst xmlns:a="http://schemas.openxmlformats.org/drawingml/2006/main">
               <a:ext uri="{FF2B5EF4-FFF2-40B4-BE49-F238E27FC236}">
-                <a16:creationId xmlns:a16="http://schemas.microsoft.com/office/drawing/2014/main" id="{D4B2AB05-F40F-47A0-98A8-34D540D79835}"/>
+                <a16:creationId xmlns:a16="http://schemas.microsoft.com/office/drawing/2014/main" id="{DC8418B0-9ECB-4651-AEE2-8AB45087715A}"/>
               </a:ext>
             </a:extLst>
           </p:cNvPr>
@@ -14692,7 +14692,7 @@
           <p:cNvPr id="5" name="">
             <a:extLst xmlns:a="http://schemas.openxmlformats.org/drawingml/2006/main">
               <a:ext uri="{FF2B5EF4-FFF2-40B4-BE49-F238E27FC236}">
-                <a16:creationId xmlns:a16="http://schemas.microsoft.com/office/drawing/2014/main" id="{543C2B70-4D52-4F4E-A355-405C4432F21F}"/>
+                <a16:creationId xmlns:a16="http://schemas.microsoft.com/office/drawing/2014/main" id="{E17CBD00-D3C9-493B-909D-7DED115CB881}"/>
               </a:ext>
             </a:extLst>
           </p:cNvPr>
@@ -14819,7 +14819,7 @@
           <p:cNvPr id="6" name="Chart">
             <a:extLst xmlns:a="http://schemas.openxmlformats.org/drawingml/2006/main">
               <a:ext uri="{FF2B5EF4-FFF2-40B4-BE49-F238E27FC236}">
-                <a16:creationId xmlns:a16="http://schemas.microsoft.com/office/drawing/2014/main" id="{37017807-AC8F-4785-BF86-2B2996E5B7D1}"/>
+                <a16:creationId xmlns:a16="http://schemas.microsoft.com/office/drawing/2014/main" id="{C33DA955-84ED-495F-8679-B7650D040BDD}"/>
               </a:ext>
             </a:extLst>
           </p:cNvPr>
@@ -14832,14 +14832,14 @@
         </p:xfrm>
         <a:graphic xmlns:a="http://schemas.openxmlformats.org/drawingml/2006/main">
           <a:graphicData uri="http://schemas.openxmlformats.org/drawingml/2006/chart">
-            <c:chart xmlns:r="http://schemas.openxmlformats.org/officeDocument/2006/relationships" xmlns:c="http://schemas.openxmlformats.org/drawingml/2006/chart" r:id="R6a56f418deab494c"/>
+            <c:chart xmlns:r="http://schemas.openxmlformats.org/officeDocument/2006/relationships" xmlns:c="http://schemas.openxmlformats.org/drawingml/2006/chart" r:id="Rb756a97eb1be4b36"/>
           </a:graphicData>
         </a:graphic>
       </p:graphicFrame>
     </p:spTree>
     <p:extLst>
       <p:ext uri="{BB962C8B-B14F-4D97-AF65-F5344CB8AC3E}">
-        <p14:creationId xmlns:p14="http://schemas.microsoft.com/office/powerpoint/2010/main" val="87505480"/>
+        <p14:creationId xmlns:p14="http://schemas.microsoft.com/office/powerpoint/2010/main" val="1739013834"/>
       </p:ext>
     </p:extLst>
   </p:cSld>
@@ -14870,7 +14870,7 @@
           <p:cNvPr id="7" name="">
             <a:extLst xmlns:a="http://schemas.openxmlformats.org/drawingml/2006/main">
               <a:ext uri="{FF2B5EF4-FFF2-40B4-BE49-F238E27FC236}">
-                <a16:creationId xmlns:a16="http://schemas.microsoft.com/office/drawing/2014/main" id="{38230323-B2F9-4C88-BEF2-7BD6502FA818}"/>
+                <a16:creationId xmlns:a16="http://schemas.microsoft.com/office/drawing/2014/main" id="{9A3E2295-8EAC-430C-BCFE-DDEDE087D3F6}"/>
               </a:ext>
             </a:extLst>
           </p:cNvPr>
@@ -14942,7 +14942,7 @@
           <p:cNvPr id="2" name="">
             <a:extLst xmlns:a="http://schemas.openxmlformats.org/drawingml/2006/main">
               <a:ext uri="{FF2B5EF4-FFF2-40B4-BE49-F238E27FC236}">
-                <a16:creationId xmlns:a16="http://schemas.microsoft.com/office/drawing/2014/main" id="{8964D2B8-402F-4BCF-B953-4405FDAA9FB9}"/>
+                <a16:creationId xmlns:a16="http://schemas.microsoft.com/office/drawing/2014/main" id="{2514B035-A329-4FEE-979F-EB633504D25D}"/>
               </a:ext>
             </a:extLst>
           </p:cNvPr>
@@ -15014,7 +15014,7 @@
           <p:cNvPr id="3" name="">
             <a:extLst xmlns:a="http://schemas.openxmlformats.org/drawingml/2006/main">
               <a:ext uri="{FF2B5EF4-FFF2-40B4-BE49-F238E27FC236}">
-                <a16:creationId xmlns:a16="http://schemas.microsoft.com/office/drawing/2014/main" id="{CBEAA358-B8B6-4685-9CE4-26024663253E}"/>
+                <a16:creationId xmlns:a16="http://schemas.microsoft.com/office/drawing/2014/main" id="{674C968D-1E9D-4D5F-BEDA-D6841CEA9804}"/>
               </a:ext>
             </a:extLst>
           </p:cNvPr>
@@ -15086,7 +15086,7 @@
           <p:cNvPr id="4" name="Chart">
             <a:extLst xmlns:a="http://schemas.openxmlformats.org/drawingml/2006/main">
               <a:ext uri="{FF2B5EF4-FFF2-40B4-BE49-F238E27FC236}">
-                <a16:creationId xmlns:a16="http://schemas.microsoft.com/office/drawing/2014/main" id="{15305996-B531-4FBE-A0FF-67DC7069654E}"/>
+                <a16:creationId xmlns:a16="http://schemas.microsoft.com/office/drawing/2014/main" id="{C333934D-CA50-4816-B17F-570C4055C976}"/>
               </a:ext>
             </a:extLst>
           </p:cNvPr>
@@ -15099,7 +15099,7 @@
         </p:xfrm>
         <a:graphic xmlns:a="http://schemas.openxmlformats.org/drawingml/2006/main">
           <a:graphicData uri="http://schemas.openxmlformats.org/drawingml/2006/chart">
-            <c:chart xmlns:r="http://schemas.openxmlformats.org/officeDocument/2006/relationships" xmlns:c="http://schemas.openxmlformats.org/drawingml/2006/chart" r:id="R13b19607eafb4789"/>
+            <c:chart xmlns:r="http://schemas.openxmlformats.org/officeDocument/2006/relationships" xmlns:c="http://schemas.openxmlformats.org/drawingml/2006/chart" r:id="R71cddadb44564e4a"/>
           </a:graphicData>
         </a:graphic>
       </p:graphicFrame>
@@ -15108,7 +15108,7 @@
           <p:cNvPr id="5" name="">
             <a:extLst xmlns:a="http://schemas.openxmlformats.org/drawingml/2006/main">
               <a:ext uri="{FF2B5EF4-FFF2-40B4-BE49-F238E27FC236}">
-                <a16:creationId xmlns:a16="http://schemas.microsoft.com/office/drawing/2014/main" id="{21CCB271-50F4-46C1-9DC4-6AAD77D327A5}"/>
+                <a16:creationId xmlns:a16="http://schemas.microsoft.com/office/drawing/2014/main" id="{DFC114CE-792B-44F4-8768-B6D1FB51EC0D}"/>
               </a:ext>
             </a:extLst>
           </p:cNvPr>
@@ -15457,7 +15457,7 @@
           <p:cNvPr id="6" name="">
             <a:extLst xmlns:a="http://schemas.openxmlformats.org/drawingml/2006/main">
               <a:ext uri="{FF2B5EF4-FFF2-40B4-BE49-F238E27FC236}">
-                <a16:creationId xmlns:a16="http://schemas.microsoft.com/office/drawing/2014/main" id="{3BA1F10D-BA67-4909-A311-6594B3057A21}"/>
+                <a16:creationId xmlns:a16="http://schemas.microsoft.com/office/drawing/2014/main" id="{22F23961-C624-4161-B2FA-768C5F8A1D01}"/>
               </a:ext>
             </a:extLst>
           </p:cNvPr>
@@ -15604,7 +15604,7 @@
     </p:spTree>
     <p:extLst>
       <p:ext uri="{BB962C8B-B14F-4D97-AF65-F5344CB8AC3E}">
-        <p14:creationId xmlns:p14="http://schemas.microsoft.com/office/powerpoint/2010/main" val="1930977856"/>
+        <p14:creationId xmlns:p14="http://schemas.microsoft.com/office/powerpoint/2010/main" val="1787734523"/>
       </p:ext>
     </p:extLst>
   </p:cSld>
@@ -15635,7 +15635,7 @@
           <p:cNvPr id="5" name="">
             <a:extLst xmlns:a="http://schemas.openxmlformats.org/drawingml/2006/main">
               <a:ext uri="{FF2B5EF4-FFF2-40B4-BE49-F238E27FC236}">
-                <a16:creationId xmlns:a16="http://schemas.microsoft.com/office/drawing/2014/main" id="{21A45FAE-2AB3-4535-8D0A-37FD56CB7100}"/>
+                <a16:creationId xmlns:a16="http://schemas.microsoft.com/office/drawing/2014/main" id="{A433AE0D-E343-4AAC-9A12-F85C4EDAA848}"/>
               </a:ext>
             </a:extLst>
           </p:cNvPr>
@@ -15707,7 +15707,7 @@
           <p:cNvPr id="2" name="">
             <a:extLst xmlns:a="http://schemas.openxmlformats.org/drawingml/2006/main">
               <a:ext uri="{FF2B5EF4-FFF2-40B4-BE49-F238E27FC236}">
-                <a16:creationId xmlns:a16="http://schemas.microsoft.com/office/drawing/2014/main" id="{D7073678-9986-4757-AB9D-F00AB269CCD4}"/>
+                <a16:creationId xmlns:a16="http://schemas.microsoft.com/office/drawing/2014/main" id="{AFD937EB-0470-40E7-82D1-671707BE4F2D}"/>
               </a:ext>
             </a:extLst>
           </p:cNvPr>
@@ -15779,7 +15779,7 @@
           <p:cNvPr id="3" name="">
             <a:extLst xmlns:a="http://schemas.openxmlformats.org/drawingml/2006/main">
               <a:ext uri="{FF2B5EF4-FFF2-40B4-BE49-F238E27FC236}">
-                <a16:creationId xmlns:a16="http://schemas.microsoft.com/office/drawing/2014/main" id="{80A400F0-5774-4310-9CD9-84F81CD306BE}"/>
+                <a16:creationId xmlns:a16="http://schemas.microsoft.com/office/drawing/2014/main" id="{7FD89A04-1268-4831-8BD9-E3B29A484D16}"/>
               </a:ext>
             </a:extLst>
           </p:cNvPr>
@@ -16274,7 +16274,7 @@
           <p:cNvPr id="4" name="">
             <a:extLst xmlns:a="http://schemas.openxmlformats.org/drawingml/2006/main">
               <a:ext uri="{FF2B5EF4-FFF2-40B4-BE49-F238E27FC236}">
-                <a16:creationId xmlns:a16="http://schemas.microsoft.com/office/drawing/2014/main" id="{F11C8E16-0FA5-49E7-9E33-4DE4DAF67CAA}"/>
+                <a16:creationId xmlns:a16="http://schemas.microsoft.com/office/drawing/2014/main" id="{15F1B8DC-06E2-4D27-A080-C5C0588205AA}"/>
               </a:ext>
             </a:extLst>
           </p:cNvPr>
@@ -16358,7 +16358,7 @@
     </p:spTree>
     <p:extLst>
       <p:ext uri="{BB962C8B-B14F-4D97-AF65-F5344CB8AC3E}">
-        <p14:creationId xmlns:p14="http://schemas.microsoft.com/office/powerpoint/2010/main" val="1275486835"/>
+        <p14:creationId xmlns:p14="http://schemas.microsoft.com/office/powerpoint/2010/main" val="2129925606"/>
       </p:ext>
     </p:extLst>
   </p:cSld>
@@ -16389,7 +16389,7 @@
           <p:cNvPr id="5" name="">
             <a:extLst xmlns:a="http://schemas.openxmlformats.org/drawingml/2006/main">
               <a:ext uri="{FF2B5EF4-FFF2-40B4-BE49-F238E27FC236}">
-                <a16:creationId xmlns:a16="http://schemas.microsoft.com/office/drawing/2014/main" id="{A23E3359-871E-4A46-9AB8-D76AB4F37368}"/>
+                <a16:creationId xmlns:a16="http://schemas.microsoft.com/office/drawing/2014/main" id="{C553EB5B-53B7-4645-A406-BD71D2748A2E}"/>
               </a:ext>
             </a:extLst>
           </p:cNvPr>
@@ -16461,7 +16461,7 @@
           <p:cNvPr id="2" name="">
             <a:extLst xmlns:a="http://schemas.openxmlformats.org/drawingml/2006/main">
               <a:ext uri="{FF2B5EF4-FFF2-40B4-BE49-F238E27FC236}">
-                <a16:creationId xmlns:a16="http://schemas.microsoft.com/office/drawing/2014/main" id="{BBA16C31-FEF1-448B-8373-7FDE84DAF815}"/>
+                <a16:creationId xmlns:a16="http://schemas.microsoft.com/office/drawing/2014/main" id="{58A967FE-901A-49B5-9A13-8DF191F37929}"/>
               </a:ext>
             </a:extLst>
           </p:cNvPr>
@@ -16533,7 +16533,7 @@
           <p:cNvPr id="3" name="">
             <a:extLst xmlns:a="http://schemas.openxmlformats.org/drawingml/2006/main">
               <a:ext uri="{FF2B5EF4-FFF2-40B4-BE49-F238E27FC236}">
-                <a16:creationId xmlns:a16="http://schemas.microsoft.com/office/drawing/2014/main" id="{6A7A7520-FCC3-4E63-84EA-AC82791D1DE8}"/>
+                <a16:creationId xmlns:a16="http://schemas.microsoft.com/office/drawing/2014/main" id="{B1663F43-617B-4261-941D-72796F50AD09}"/>
               </a:ext>
             </a:extLst>
           </p:cNvPr>
@@ -16701,7 +16701,7 @@
           <p:cNvPr id="4" name="">
             <a:extLst xmlns:a="http://schemas.openxmlformats.org/drawingml/2006/main">
               <a:ext uri="{FF2B5EF4-FFF2-40B4-BE49-F238E27FC236}">
-                <a16:creationId xmlns:a16="http://schemas.microsoft.com/office/drawing/2014/main" id="{AABEE90B-87FD-4677-8819-3830875576F8}"/>
+                <a16:creationId xmlns:a16="http://schemas.microsoft.com/office/drawing/2014/main" id="{FB43385F-A4B2-4E75-A53B-859E2D170E85}"/>
               </a:ext>
             </a:extLst>
           </p:cNvPr>
@@ -16771,7 +16771,7 @@
     </p:spTree>
     <p:extLst>
       <p:ext uri="{BB962C8B-B14F-4D97-AF65-F5344CB8AC3E}">
-        <p14:creationId xmlns:p14="http://schemas.microsoft.com/office/powerpoint/2010/main" val="1113264122"/>
+        <p14:creationId xmlns:p14="http://schemas.microsoft.com/office/powerpoint/2010/main" val="900361283"/>
       </p:ext>
     </p:extLst>
   </p:cSld>
@@ -16802,7 +16802,7 @@
           <p:cNvPr id="4" name="">
             <a:extLst xmlns:a="http://schemas.openxmlformats.org/drawingml/2006/main">
               <a:ext uri="{FF2B5EF4-FFF2-40B4-BE49-F238E27FC236}">
-                <a16:creationId xmlns:a16="http://schemas.microsoft.com/office/drawing/2014/main" id="{34A1B8D6-46A1-4670-A6D3-7E3955AA1FF9}"/>
+                <a16:creationId xmlns:a16="http://schemas.microsoft.com/office/drawing/2014/main" id="{B601C6EB-0B0C-4275-9B96-6EAFCB19435E}"/>
               </a:ext>
             </a:extLst>
           </p:cNvPr>
@@ -16874,7 +16874,7 @@
           <p:cNvPr id="2" name="">
             <a:extLst xmlns:a="http://schemas.openxmlformats.org/drawingml/2006/main">
               <a:ext uri="{FF2B5EF4-FFF2-40B4-BE49-F238E27FC236}">
-                <a16:creationId xmlns:a16="http://schemas.microsoft.com/office/drawing/2014/main" id="{DE6AFFE9-673C-4D87-90B6-F173A10D0DB3}"/>
+                <a16:creationId xmlns:a16="http://schemas.microsoft.com/office/drawing/2014/main" id="{33878D01-2C96-4323-BA89-467E1C8A1F87}"/>
               </a:ext>
             </a:extLst>
           </p:cNvPr>
@@ -16946,7 +16946,7 @@
           <p:cNvPr id="3" name="">
             <a:extLst xmlns:a="http://schemas.openxmlformats.org/drawingml/2006/main">
               <a:ext uri="{FF2B5EF4-FFF2-40B4-BE49-F238E27FC236}">
-                <a16:creationId xmlns:a16="http://schemas.microsoft.com/office/drawing/2014/main" id="{86DFE005-CDAD-4701-9B44-A86E2119669E}"/>
+                <a16:creationId xmlns:a16="http://schemas.microsoft.com/office/drawing/2014/main" id="{D4758B7E-E112-4ECF-8871-7FF8CA8B00FB}"/>
               </a:ext>
             </a:extLst>
           </p:cNvPr>
@@ -17112,7 +17112,7 @@
     </p:spTree>
     <p:extLst>
       <p:ext uri="{BB962C8B-B14F-4D97-AF65-F5344CB8AC3E}">
-        <p14:creationId xmlns:p14="http://schemas.microsoft.com/office/powerpoint/2010/main" val="1152366413"/>
+        <p14:creationId xmlns:p14="http://schemas.microsoft.com/office/powerpoint/2010/main" val="307298243"/>
       </p:ext>
     </p:extLst>
   </p:cSld>
@@ -17143,7 +17143,7 @@
           <p:cNvPr id="4" name="">
             <a:extLst xmlns:a="http://schemas.openxmlformats.org/drawingml/2006/main">
               <a:ext uri="{FF2B5EF4-FFF2-40B4-BE49-F238E27FC236}">
-                <a16:creationId xmlns:a16="http://schemas.microsoft.com/office/drawing/2014/main" id="{0DE2DD59-8E6C-4383-9B86-ED0B73B25C63}"/>
+                <a16:creationId xmlns:a16="http://schemas.microsoft.com/office/drawing/2014/main" id="{C8A1E807-7AE7-4CDB-9EBA-796E22F2D216}"/>
               </a:ext>
             </a:extLst>
           </p:cNvPr>
@@ -17215,7 +17215,7 @@
           <p:cNvPr id="2" name="">
             <a:extLst xmlns:a="http://schemas.openxmlformats.org/drawingml/2006/main">
               <a:ext uri="{FF2B5EF4-FFF2-40B4-BE49-F238E27FC236}">
-                <a16:creationId xmlns:a16="http://schemas.microsoft.com/office/drawing/2014/main" id="{AA8A05FC-7C74-4F96-9A35-B1CF760F8C81}"/>
+                <a16:creationId xmlns:a16="http://schemas.microsoft.com/office/drawing/2014/main" id="{B965E314-DC30-497C-98BA-C8B3E07697EA}"/>
               </a:ext>
             </a:extLst>
           </p:cNvPr>
@@ -17287,7 +17287,7 @@
           <p:cNvPr id="3" name="">
             <a:extLst xmlns:a="http://schemas.openxmlformats.org/drawingml/2006/main">
               <a:ext uri="{FF2B5EF4-FFF2-40B4-BE49-F238E27FC236}">
-                <a16:creationId xmlns:a16="http://schemas.microsoft.com/office/drawing/2014/main" id="{7F6D21BD-AF4E-487A-9A1F-0F29B75DAD7D}"/>
+                <a16:creationId xmlns:a16="http://schemas.microsoft.com/office/drawing/2014/main" id="{5F14AB63-D0F6-4FA5-B6D7-F6E97AACFE1F}"/>
               </a:ext>
             </a:extLst>
           </p:cNvPr>
@@ -17535,7 +17535,7 @@
     </p:spTree>
     <p:extLst>
       <p:ext uri="{BB962C8B-B14F-4D97-AF65-F5344CB8AC3E}">
-        <p14:creationId xmlns:p14="http://schemas.microsoft.com/office/powerpoint/2010/main" val="2105903332"/>
+        <p14:creationId xmlns:p14="http://schemas.microsoft.com/office/powerpoint/2010/main" val="608619204"/>
       </p:ext>
     </p:extLst>
   </p:cSld>
@@ -17566,7 +17566,7 @@
           <p:cNvPr id="4" name="">
             <a:extLst xmlns:a="http://schemas.openxmlformats.org/drawingml/2006/main">
               <a:ext uri="{FF2B5EF4-FFF2-40B4-BE49-F238E27FC236}">
-                <a16:creationId xmlns:a16="http://schemas.microsoft.com/office/drawing/2014/main" id="{3B44B380-58BA-4307-8027-A6627E2C0ADB}"/>
+                <a16:creationId xmlns:a16="http://schemas.microsoft.com/office/drawing/2014/main" id="{F51EBB9A-20D7-4814-83C6-532DD42452FD}"/>
               </a:ext>
             </a:extLst>
           </p:cNvPr>
@@ -17638,7 +17638,7 @@
           <p:cNvPr id="2" name="">
             <a:extLst xmlns:a="http://schemas.openxmlformats.org/drawingml/2006/main">
               <a:ext uri="{FF2B5EF4-FFF2-40B4-BE49-F238E27FC236}">
-                <a16:creationId xmlns:a16="http://schemas.microsoft.com/office/drawing/2014/main" id="{F9D67C24-7F65-4132-99EA-B5EF24C58EBC}"/>
+                <a16:creationId xmlns:a16="http://schemas.microsoft.com/office/drawing/2014/main" id="{D69E1C61-6C87-41F5-888B-68B2A503AB3D}"/>
               </a:ext>
             </a:extLst>
           </p:cNvPr>
@@ -17710,7 +17710,7 @@
           <p:cNvPr id="3" name="">
             <a:extLst xmlns:a="http://schemas.openxmlformats.org/drawingml/2006/main">
               <a:ext uri="{FF2B5EF4-FFF2-40B4-BE49-F238E27FC236}">
-                <a16:creationId xmlns:a16="http://schemas.microsoft.com/office/drawing/2014/main" id="{E023EE4C-44A2-4FD7-8389-5CF86DB51CDB}"/>
+                <a16:creationId xmlns:a16="http://schemas.microsoft.com/office/drawing/2014/main" id="{70FB8505-5BEF-4385-9772-7B9EF7C6A6A8}"/>
               </a:ext>
             </a:extLst>
           </p:cNvPr>
@@ -17928,7 +17928,7 @@
                 <a:ea typeface="Helvetica Neue"/>
                 <a:cs typeface="Helvetica Neue"/>
               </a:rPr>
-              <a:t>Эффект проверен на двух масштабах: </a:t>
+              <a:t>Эксперименты проведены с </a:t>
             </a:r>
             <a:r>
               <a:rPr sz="1950" b="1">
@@ -17939,7 +17939,7 @@
                 <a:ea typeface="Helvetica Neue"/>
                 <a:cs typeface="Helvetica Neue"/>
               </a:rPr>
-              <a:t>LeNet / MNIST</a:t>
+              <a:t>LeNet на MNIST</a:t>
             </a:r>
             <a:r>
               <a:rPr sz="1950">
@@ -17961,7 +17961,7 @@
                 <a:ea typeface="Helvetica Neue"/>
                 <a:cs typeface="Helvetica Neue"/>
               </a:rPr>
-              <a:t>ResNet-56 / CIFAR-10</a:t>
+              <a:t>ResNet-56 на CIFAR-10</a:t>
             </a:r>
             <a:r>
               <a:rPr sz="1950">
@@ -17980,7 +17980,7 @@
     </p:spTree>
     <p:extLst>
       <p:ext uri="{BB962C8B-B14F-4D97-AF65-F5344CB8AC3E}">
-        <p14:creationId xmlns:p14="http://schemas.microsoft.com/office/powerpoint/2010/main" val="1002522307"/>
+        <p14:creationId xmlns:p14="http://schemas.microsoft.com/office/powerpoint/2010/main" val="975308538"/>
       </p:ext>
     </p:extLst>
   </p:cSld>
@@ -18011,7 +18011,7 @@
           <p:cNvPr id="6" name="">
             <a:extLst xmlns:a="http://schemas.openxmlformats.org/drawingml/2006/main">
               <a:ext uri="{FF2B5EF4-FFF2-40B4-BE49-F238E27FC236}">
-                <a16:creationId xmlns:a16="http://schemas.microsoft.com/office/drawing/2014/main" id="{7FA8F73D-57DB-4581-B30B-148EC5F6616E}"/>
+                <a16:creationId xmlns:a16="http://schemas.microsoft.com/office/drawing/2014/main" id="{515B1C5F-A857-46A1-9833-BAC677397322}"/>
               </a:ext>
             </a:extLst>
           </p:cNvPr>
@@ -18083,7 +18083,7 @@
           <p:cNvPr id="2" name="">
             <a:extLst xmlns:a="http://schemas.openxmlformats.org/drawingml/2006/main">
               <a:ext uri="{FF2B5EF4-FFF2-40B4-BE49-F238E27FC236}">
-                <a16:creationId xmlns:a16="http://schemas.microsoft.com/office/drawing/2014/main" id="{91E42747-96A0-44F2-8D90-97D4C6C4F31D}"/>
+                <a16:creationId xmlns:a16="http://schemas.microsoft.com/office/drawing/2014/main" id="{36727771-F101-412A-B294-BF709F9D4A53}"/>
               </a:ext>
             </a:extLst>
           </p:cNvPr>
@@ -18155,7 +18155,7 @@
           <p:cNvPr id="3" name="">
             <a:extLst xmlns:a="http://schemas.openxmlformats.org/drawingml/2006/main">
               <a:ext uri="{FF2B5EF4-FFF2-40B4-BE49-F238E27FC236}">
-                <a16:creationId xmlns:a16="http://schemas.microsoft.com/office/drawing/2014/main" id="{9A46B6F5-331A-41E2-A6EF-24337DF34FF9}"/>
+                <a16:creationId xmlns:a16="http://schemas.microsoft.com/office/drawing/2014/main" id="{819EFD3F-EB1A-4F99-986C-77FB8D8A2B61}"/>
               </a:ext>
             </a:extLst>
           </p:cNvPr>
@@ -18249,7 +18249,7 @@
           <p:cNvPr id="4" name="">
             <a:extLst xmlns:a="http://schemas.openxmlformats.org/drawingml/2006/main">
               <a:ext uri="{FF2B5EF4-FFF2-40B4-BE49-F238E27FC236}">
-                <a16:creationId xmlns:a16="http://schemas.microsoft.com/office/drawing/2014/main" id="{12108241-579F-48B4-A664-0515E4A46E79}"/>
+                <a16:creationId xmlns:a16="http://schemas.microsoft.com/office/drawing/2014/main" id="{BE445564-C9FE-4D4B-AB00-FA5E2D1ABC96}"/>
               </a:ext>
             </a:extLst>
           </p:cNvPr>
@@ -18321,7 +18321,7 @@
           <p:cNvPr id="5" name="">
             <a:extLst xmlns:a="http://schemas.openxmlformats.org/drawingml/2006/main">
               <a:ext uri="{FF2B5EF4-FFF2-40B4-BE49-F238E27FC236}">
-                <a16:creationId xmlns:a16="http://schemas.microsoft.com/office/drawing/2014/main" id="{58A739AB-A0A4-4FEA-8376-9C35834BCD62}"/>
+                <a16:creationId xmlns:a16="http://schemas.microsoft.com/office/drawing/2014/main" id="{ADD67174-C71A-4279-BA67-BB7DB646CE1B}"/>
               </a:ext>
             </a:extLst>
           </p:cNvPr>
@@ -18528,7 +18528,7 @@
     </p:spTree>
     <p:extLst>
       <p:ext uri="{BB962C8B-B14F-4D97-AF65-F5344CB8AC3E}">
-        <p14:creationId xmlns:p14="http://schemas.microsoft.com/office/powerpoint/2010/main" val="577360698"/>
+        <p14:creationId xmlns:p14="http://schemas.microsoft.com/office/powerpoint/2010/main" val="491364408"/>
       </p:ext>
     </p:extLst>
   </p:cSld>
@@ -18559,7 +18559,7 @@
           <p:cNvPr id="7" name="">
             <a:extLst xmlns:a="http://schemas.openxmlformats.org/drawingml/2006/main">
               <a:ext uri="{FF2B5EF4-FFF2-40B4-BE49-F238E27FC236}">
-                <a16:creationId xmlns:a16="http://schemas.microsoft.com/office/drawing/2014/main" id="{D178BE18-00B8-44B4-9ADE-A2EECF5EC4DE}"/>
+                <a16:creationId xmlns:a16="http://schemas.microsoft.com/office/drawing/2014/main" id="{35418473-2F08-497E-B6A2-0C860502BE7E}"/>
               </a:ext>
             </a:extLst>
           </p:cNvPr>
@@ -18631,7 +18631,7 @@
           <p:cNvPr id="2" name="">
             <a:extLst xmlns:a="http://schemas.openxmlformats.org/drawingml/2006/main">
               <a:ext uri="{FF2B5EF4-FFF2-40B4-BE49-F238E27FC236}">
-                <a16:creationId xmlns:a16="http://schemas.microsoft.com/office/drawing/2014/main" id="{65AF5C1F-24A8-41B6-84AF-538D6D17CB99}"/>
+                <a16:creationId xmlns:a16="http://schemas.microsoft.com/office/drawing/2014/main" id="{55564EE6-C4D5-4B56-9DBE-65F8082521B1}"/>
               </a:ext>
             </a:extLst>
           </p:cNvPr>
@@ -18703,7 +18703,7 @@
           <p:cNvPr id="3" name="">
             <a:extLst xmlns:a="http://schemas.openxmlformats.org/drawingml/2006/main">
               <a:ext uri="{FF2B5EF4-FFF2-40B4-BE49-F238E27FC236}">
-                <a16:creationId xmlns:a16="http://schemas.microsoft.com/office/drawing/2014/main" id="{CE50B81A-CD47-4E22-A004-AAF56CD32C5D}"/>
+                <a16:creationId xmlns:a16="http://schemas.microsoft.com/office/drawing/2014/main" id="{4C171DEE-8FB1-40CF-A1EF-36FCEF521581}"/>
               </a:ext>
             </a:extLst>
           </p:cNvPr>
@@ -18775,7 +18775,7 @@
           <p:cNvPr id="4" name="">
             <a:extLst xmlns:a="http://schemas.openxmlformats.org/drawingml/2006/main">
               <a:ext uri="{FF2B5EF4-FFF2-40B4-BE49-F238E27FC236}">
-                <a16:creationId xmlns:a16="http://schemas.microsoft.com/office/drawing/2014/main" id="{161E9ABE-8E8A-44E4-9F5F-788BBF56C5C6}"/>
+                <a16:creationId xmlns:a16="http://schemas.microsoft.com/office/drawing/2014/main" id="{F062A469-100F-4099-821C-B330E27BF6D5}"/>
               </a:ext>
             </a:extLst>
           </p:cNvPr>
@@ -18847,7 +18847,7 @@
           <p:cNvPr id="5" name="">
             <a:extLst xmlns:a="http://schemas.openxmlformats.org/drawingml/2006/main">
               <a:ext uri="{FF2B5EF4-FFF2-40B4-BE49-F238E27FC236}">
-                <a16:creationId xmlns:a16="http://schemas.microsoft.com/office/drawing/2014/main" id="{32542864-9FE6-4160-97E6-564FA2D5DC6A}"/>
+                <a16:creationId xmlns:a16="http://schemas.microsoft.com/office/drawing/2014/main" id="{D274E594-E70E-43BE-94A5-39A2DB5D48E6}"/>
               </a:ext>
             </a:extLst>
           </p:cNvPr>
@@ -18919,7 +18919,7 @@
           <p:cNvPr id="6" name="">
             <a:extLst xmlns:a="http://schemas.openxmlformats.org/drawingml/2006/main">
               <a:ext uri="{FF2B5EF4-FFF2-40B4-BE49-F238E27FC236}">
-                <a16:creationId xmlns:a16="http://schemas.microsoft.com/office/drawing/2014/main" id="{30DED619-CDC8-480E-A35E-182672C4A203}"/>
+                <a16:creationId xmlns:a16="http://schemas.microsoft.com/office/drawing/2014/main" id="{1F547EA1-7AAD-4155-9C99-C85C9E16F4B7}"/>
               </a:ext>
             </a:extLst>
           </p:cNvPr>
@@ -19044,7 +19044,7 @@
     </p:spTree>
     <p:extLst>
       <p:ext uri="{BB962C8B-B14F-4D97-AF65-F5344CB8AC3E}">
-        <p14:creationId xmlns:p14="http://schemas.microsoft.com/office/powerpoint/2010/main" val="266392108"/>
+        <p14:creationId xmlns:p14="http://schemas.microsoft.com/office/powerpoint/2010/main" val="2133679279"/>
       </p:ext>
     </p:extLst>
   </p:cSld>
@@ -19072,10 +19072,10 @@
       </p:grpSpPr>
       <p:sp>
         <p:nvSpPr>
-          <p:cNvPr id="5" name="">
+          <p:cNvPr id="4" name="">
             <a:extLst xmlns:a="http://schemas.openxmlformats.org/drawingml/2006/main">
               <a:ext uri="{FF2B5EF4-FFF2-40B4-BE49-F238E27FC236}">
-                <a16:creationId xmlns:a16="http://schemas.microsoft.com/office/drawing/2014/main" id="{A9AB16A3-764D-456D-9FEB-87DA1F4164F3}"/>
+                <a16:creationId xmlns:a16="http://schemas.microsoft.com/office/drawing/2014/main" id="{AED39449-5D4B-4DBF-9F1C-1B4D33F61913}"/>
               </a:ext>
             </a:extLst>
           </p:cNvPr>
@@ -19147,7 +19147,7 @@
           <p:cNvPr id="2" name="">
             <a:extLst xmlns:a="http://schemas.openxmlformats.org/drawingml/2006/main">
               <a:ext uri="{FF2B5EF4-FFF2-40B4-BE49-F238E27FC236}">
-                <a16:creationId xmlns:a16="http://schemas.microsoft.com/office/drawing/2014/main" id="{B49BDD20-A4F9-45C6-B0BF-0C61F41D0197}"/>
+                <a16:creationId xmlns:a16="http://schemas.microsoft.com/office/drawing/2014/main" id="{418E153E-E9AD-45FC-A68D-A4469B063618}"/>
               </a:ext>
             </a:extLst>
           </p:cNvPr>
@@ -19219,7 +19219,7 @@
           <p:cNvPr id="3" name="">
             <a:extLst xmlns:a="http://schemas.openxmlformats.org/drawingml/2006/main">
               <a:ext uri="{FF2B5EF4-FFF2-40B4-BE49-F238E27FC236}">
-                <a16:creationId xmlns:a16="http://schemas.microsoft.com/office/drawing/2014/main" id="{85F92B6B-96C9-4094-8081-16F5B5222E87}"/>
+                <a16:creationId xmlns:a16="http://schemas.microsoft.com/office/drawing/2014/main" id="{8C539EB6-3ADC-4A7C-829E-50C5693843C1}"/>
               </a:ext>
             </a:extLst>
           </p:cNvPr>
@@ -19423,109 +19423,10 @@
           </a:p>
         </p:txBody>
       </p:sp>
-      <p:sp>
-        <p:nvSpPr>
-          <p:cNvPr id="4" name="">
-            <a:extLst xmlns:a="http://schemas.openxmlformats.org/drawingml/2006/main">
-              <a:ext uri="{FF2B5EF4-FFF2-40B4-BE49-F238E27FC236}">
-                <a16:creationId xmlns:a16="http://schemas.microsoft.com/office/drawing/2014/main" id="{D91E2C42-7872-4253-A09F-95E8151F2C48}"/>
-              </a:ext>
-            </a:extLst>
-          </p:cNvPr>
-          <p:cNvSpPr>
-            <a:spLocks xmlns:a="http://schemas.openxmlformats.org/drawingml/2006/main" noGrp="1"/>
-          </p:cNvSpPr>
-          <p:nvPr/>
-        </p:nvSpPr>
-        <p:spPr>
-          <a:xfrm xmlns:a="http://schemas.openxmlformats.org/drawingml/2006/main">
-            <a:off x="609600" y="5495925"/>
-            <a:ext cx="10972800" cy="704850"/>
-          </a:xfrm>
-          <a:prstGeom xmlns:a="http://schemas.openxmlformats.org/drawingml/2006/main" prst="rect">
-            <a:avLst/>
-          </a:prstGeom>
-          <a:noFill xmlns:a="http://schemas.openxmlformats.org/drawingml/2006/main"/>
-          <a:ln xmlns:a="http://schemas.openxmlformats.org/drawingml/2006/main" w="0">
-            <a:noFill/>
-          </a:ln>
-        </p:spPr>
-        <p:txBody>
-          <a:bodyPr xmlns:a="http://schemas.openxmlformats.org/drawingml/2006/main" lIns="0" tIns="0" rIns="0" bIns="0" anchor="t">
-            <a:noAutofit/>
-          </a:bodyPr>
-          <a:lstStyle xmlns:a="http://schemas.openxmlformats.org/drawingml/2006/main">
-            <a:defPPr>
-              <a:defRPr sz="1500">
-                <a:solidFill>
-                  <a:srgbClr val="555555"/>
-                </a:solidFill>
-                <a:latin typeface="Helvetica Neue"/>
-                <a:ea typeface="Helvetica Neue"/>
-                <a:cs typeface="Helvetica Neue"/>
-              </a:defRPr>
-            </a:defPPr>
-          </a:lstStyle>
-          <a:p xmlns:a="http://schemas.openxmlformats.org/drawingml/2006/main">
-            <a:pPr>
-              <a:lnSpc>
-                <a:spcPct val="123000"/>
-              </a:lnSpc>
-              <a:buNone/>
-              <a:defRPr sz="1500">
-                <a:solidFill>
-                  <a:srgbClr val="555555"/>
-                </a:solidFill>
-                <a:latin typeface="Helvetica Neue"/>
-                <a:ea typeface="Helvetica Neue"/>
-                <a:cs typeface="Helvetica Neue"/>
-              </a:defRPr>
-            </a:pPr>
-            <a:r>
-              <a:rPr sz="1500">
-                <a:solidFill>
-                  <a:srgbClr val="555555"/>
-                </a:solidFill>
-                <a:latin typeface="Helvetica Neue"/>
-                <a:ea typeface="Helvetica Neue"/>
-                <a:cs typeface="Helvetica Neue"/>
-              </a:rPr>
-              <a:t>В воспроизведении границы LR и бюджеты заданы опубликованным протоколом.</a:t>
-            </a:r>
-          </a:p>
-          <a:p xmlns:a="http://schemas.openxmlformats.org/drawingml/2006/main">
-            <a:pPr>
-              <a:lnSpc>
-                <a:spcPct val="123000"/>
-              </a:lnSpc>
-              <a:buNone/>
-              <a:defRPr sz="1500">
-                <a:solidFill>
-                  <a:srgbClr val="555555"/>
-                </a:solidFill>
-                <a:latin typeface="Helvetica Neue"/>
-                <a:ea typeface="Helvetica Neue"/>
-                <a:cs typeface="Helvetica Neue"/>
-              </a:defRPr>
-            </a:pPr>
-            <a:r>
-              <a:rPr sz="1500">
-                <a:solidFill>
-                  <a:srgbClr val="555555"/>
-                </a:solidFill>
-                <a:latin typeface="Helvetica Neue"/>
-                <a:ea typeface="Helvetica Neue"/>
-                <a:cs typeface="Helvetica Neue"/>
-              </a:rPr>
-              <a:t>LR range test и подбор гиперпараметров не повторялись.</a:t>
-            </a:r>
-          </a:p>
-        </p:txBody>
-      </p:sp>
     </p:spTree>
     <p:extLst>
       <p:ext uri="{BB962C8B-B14F-4D97-AF65-F5344CB8AC3E}">
-        <p14:creationId xmlns:p14="http://schemas.microsoft.com/office/powerpoint/2010/main" val="1899402680"/>
+        <p14:creationId xmlns:p14="http://schemas.microsoft.com/office/powerpoint/2010/main" val="868668578"/>
       </p:ext>
     </p:extLst>
   </p:cSld>
@@ -19553,10 +19454,10 @@
       </p:grpSpPr>
       <p:sp>
         <p:nvSpPr>
-          <p:cNvPr id="6" name="">
+          <p:cNvPr id="5" name="">
             <a:extLst xmlns:a="http://schemas.openxmlformats.org/drawingml/2006/main">
               <a:ext uri="{FF2B5EF4-FFF2-40B4-BE49-F238E27FC236}">
-                <a16:creationId xmlns:a16="http://schemas.microsoft.com/office/drawing/2014/main" id="{F90C7178-2375-421B-8E49-2ABB4BA924F7}"/>
+                <a16:creationId xmlns:a16="http://schemas.microsoft.com/office/drawing/2014/main" id="{8516B92D-0D30-461A-81E9-92AF6C543CA5}"/>
               </a:ext>
             </a:extLst>
           </p:cNvPr>
@@ -19628,7 +19529,7 @@
           <p:cNvPr id="2" name="">
             <a:extLst xmlns:a="http://schemas.openxmlformats.org/drawingml/2006/main">
               <a:ext uri="{FF2B5EF4-FFF2-40B4-BE49-F238E27FC236}">
-                <a16:creationId xmlns:a16="http://schemas.microsoft.com/office/drawing/2014/main" id="{21573294-4918-4FDA-91B9-D04060F01484}"/>
+                <a16:creationId xmlns:a16="http://schemas.microsoft.com/office/drawing/2014/main" id="{FF8D4A01-3283-4757-B90F-F7BE2A7B0D30}"/>
               </a:ext>
             </a:extLst>
           </p:cNvPr>
@@ -19700,7 +19601,7 @@
           <p:cNvPr id="3" name="">
             <a:extLst xmlns:a="http://schemas.openxmlformats.org/drawingml/2006/main">
               <a:ext uri="{FF2B5EF4-FFF2-40B4-BE49-F238E27FC236}">
-                <a16:creationId xmlns:a16="http://schemas.microsoft.com/office/drawing/2014/main" id="{D2A37F5B-F08D-424A-9B31-8E9587A58D6E}"/>
+                <a16:creationId xmlns:a16="http://schemas.microsoft.com/office/drawing/2014/main" id="{C653E8BA-F57A-4D1C-8172-EF08FE84386A}"/>
               </a:ext>
             </a:extLst>
           </p:cNvPr>
@@ -20075,7 +19976,7 @@
           <p:cNvPr id="4" name="">
             <a:extLst xmlns:a="http://schemas.openxmlformats.org/drawingml/2006/main">
               <a:ext uri="{FF2B5EF4-FFF2-40B4-BE49-F238E27FC236}">
-                <a16:creationId xmlns:a16="http://schemas.microsoft.com/office/drawing/2014/main" id="{BA63B1F8-AD0B-4F40-A15F-F78416214DDB}"/>
+                <a16:creationId xmlns:a16="http://schemas.microsoft.com/office/drawing/2014/main" id="{02D01382-F706-448D-A0C9-DA2BA1D5915E}"/>
               </a:ext>
             </a:extLst>
           </p:cNvPr>
@@ -20186,82 +20087,10 @@
           </a:p>
         </p:txBody>
       </p:sp>
-      <p:sp>
-        <p:nvSpPr>
-          <p:cNvPr id="5" name="">
-            <a:extLst xmlns:a="http://schemas.openxmlformats.org/drawingml/2006/main">
-              <a:ext uri="{FF2B5EF4-FFF2-40B4-BE49-F238E27FC236}">
-                <a16:creationId xmlns:a16="http://schemas.microsoft.com/office/drawing/2014/main" id="{AB4C77FB-41AC-4F81-AD03-56F2BB33BE66}"/>
-              </a:ext>
-            </a:extLst>
-          </p:cNvPr>
-          <p:cNvSpPr>
-            <a:spLocks xmlns:a="http://schemas.openxmlformats.org/drawingml/2006/main" noGrp="1"/>
-          </p:cNvSpPr>
-          <p:nvPr/>
-        </p:nvSpPr>
-        <p:spPr>
-          <a:xfrm xmlns:a="http://schemas.openxmlformats.org/drawingml/2006/main">
-            <a:off x="609600" y="5800725"/>
-            <a:ext cx="10972800" cy="304800"/>
-          </a:xfrm>
-          <a:prstGeom xmlns:a="http://schemas.openxmlformats.org/drawingml/2006/main" prst="rect">
-            <a:avLst/>
-          </a:prstGeom>
-          <a:noFill xmlns:a="http://schemas.openxmlformats.org/drawingml/2006/main"/>
-          <a:ln xmlns:a="http://schemas.openxmlformats.org/drawingml/2006/main" w="0">
-            <a:noFill/>
-          </a:ln>
-        </p:spPr>
-        <p:txBody>
-          <a:bodyPr xmlns:a="http://schemas.openxmlformats.org/drawingml/2006/main" lIns="0" tIns="0" rIns="0" bIns="0" anchor="t">
-            <a:noAutofit/>
-          </a:bodyPr>
-          <a:lstStyle xmlns:a="http://schemas.openxmlformats.org/drawingml/2006/main">
-            <a:defPPr>
-              <a:defRPr sz="1425">
-                <a:solidFill>
-                  <a:srgbClr val="555555"/>
-                </a:solidFill>
-                <a:latin typeface="Helvetica Neue"/>
-                <a:ea typeface="Helvetica Neue"/>
-                <a:cs typeface="Helvetica Neue"/>
-              </a:defRPr>
-            </a:defPPr>
-          </a:lstStyle>
-          <a:p xmlns:a="http://schemas.openxmlformats.org/drawingml/2006/main">
-            <a:pPr>
-              <a:lnSpc>
-                <a:spcPct val="123000"/>
-              </a:lnSpc>
-              <a:buNone/>
-              <a:defRPr sz="1425">
-                <a:solidFill>
-                  <a:srgbClr val="555555"/>
-                </a:solidFill>
-                <a:latin typeface="Helvetica Neue"/>
-                <a:ea typeface="Helvetica Neue"/>
-                <a:cs typeface="Helvetica Neue"/>
-              </a:defRPr>
-            </a:pPr>
-            <a:r>
-              <a:rPr sz="1425">
-                <a:solidFill>
-                  <a:srgbClr val="555555"/>
-                </a:solidFill>
-                <a:latin typeface="Helvetica Neue"/>
-                <a:ea typeface="Helvetica Neue"/>
-                <a:cs typeface="Helvetica Neue"/>
-              </a:rPr>
-              <a:t>CIFAR: рис. 1a. MNIST: табл. 2, финальная точность ± стандартное отклонение.</a:t>
-            </a:r>
-          </a:p>
-        </p:txBody>
-      </p:sp>
     </p:spTree>
     <p:extLst>
       <p:ext uri="{BB962C8B-B14F-4D97-AF65-F5344CB8AC3E}">
-        <p14:creationId xmlns:p14="http://schemas.microsoft.com/office/powerpoint/2010/main" val="884824980"/>
+        <p14:creationId xmlns:p14="http://schemas.microsoft.com/office/powerpoint/2010/main" val="234552962"/>
       </p:ext>
     </p:extLst>
   </p:cSld>
@@ -20292,7 +20121,7 @@
           <p:cNvPr id="5" name="">
             <a:extLst xmlns:a="http://schemas.openxmlformats.org/drawingml/2006/main">
               <a:ext uri="{FF2B5EF4-FFF2-40B4-BE49-F238E27FC236}">
-                <a16:creationId xmlns:a16="http://schemas.microsoft.com/office/drawing/2014/main" id="{88412541-C75E-405B-9637-8B29BE34D63D}"/>
+                <a16:creationId xmlns:a16="http://schemas.microsoft.com/office/drawing/2014/main" id="{8D8D5B0D-DFB2-478A-9058-7450015A54B1}"/>
               </a:ext>
             </a:extLst>
           </p:cNvPr>
@@ -20364,7 +20193,7 @@
           <p:cNvPr id="2" name="">
             <a:extLst xmlns:a="http://schemas.openxmlformats.org/drawingml/2006/main">
               <a:ext uri="{FF2B5EF4-FFF2-40B4-BE49-F238E27FC236}">
-                <a16:creationId xmlns:a16="http://schemas.microsoft.com/office/drawing/2014/main" id="{C91148A3-6679-4998-A598-3B6BE5D64712}"/>
+                <a16:creationId xmlns:a16="http://schemas.microsoft.com/office/drawing/2014/main" id="{D7667FD0-7D32-49BE-BED9-FE5FD3B424C1}"/>
               </a:ext>
             </a:extLst>
           </p:cNvPr>
@@ -20436,7 +20265,7 @@
           <p:cNvPr id="3" name="">
             <a:extLst xmlns:a="http://schemas.openxmlformats.org/drawingml/2006/main">
               <a:ext uri="{FF2B5EF4-FFF2-40B4-BE49-F238E27FC236}">
-                <a16:creationId xmlns:a16="http://schemas.microsoft.com/office/drawing/2014/main" id="{30C3E5E7-2AD7-48DC-9002-4B2BABD8EA4C}"/>
+                <a16:creationId xmlns:a16="http://schemas.microsoft.com/office/drawing/2014/main" id="{934600D7-2D28-4164-A2D6-5E1F879BAB93}"/>
               </a:ext>
             </a:extLst>
           </p:cNvPr>
@@ -21103,7 +20932,7 @@
           <p:cNvPr id="4" name="">
             <a:extLst xmlns:a="http://schemas.openxmlformats.org/drawingml/2006/main">
               <a:ext uri="{FF2B5EF4-FFF2-40B4-BE49-F238E27FC236}">
-                <a16:creationId xmlns:a16="http://schemas.microsoft.com/office/drawing/2014/main" id="{8761EF16-C1C3-4D3B-A325-AF60D669E0AB}"/>
+                <a16:creationId xmlns:a16="http://schemas.microsoft.com/office/drawing/2014/main" id="{73290740-89C0-429D-9118-AB478D1D9BF5}"/>
               </a:ext>
             </a:extLst>
           </p:cNvPr>
@@ -21205,7 +21034,7 @@
     </p:spTree>
     <p:extLst>
       <p:ext uri="{BB962C8B-B14F-4D97-AF65-F5344CB8AC3E}">
-        <p14:creationId xmlns:p14="http://schemas.microsoft.com/office/powerpoint/2010/main" val="791027668"/>
+        <p14:creationId xmlns:p14="http://schemas.microsoft.com/office/powerpoint/2010/main" val="1066740738"/>
       </p:ext>
     </p:extLst>
   </p:cSld>
@@ -21236,7 +21065,7 @@
           <p:cNvPr id="6" name="">
             <a:extLst xmlns:a="http://schemas.openxmlformats.org/drawingml/2006/main">
               <a:ext uri="{FF2B5EF4-FFF2-40B4-BE49-F238E27FC236}">
-                <a16:creationId xmlns:a16="http://schemas.microsoft.com/office/drawing/2014/main" id="{09EA9999-6AAC-4DAD-A392-778EBAE64FD9}"/>
+                <a16:creationId xmlns:a16="http://schemas.microsoft.com/office/drawing/2014/main" id="{82B24B73-E07D-4DE9-B0E0-637C62081897}"/>
               </a:ext>
             </a:extLst>
           </p:cNvPr>
@@ -21308,7 +21137,7 @@
           <p:cNvPr id="2" name="">
             <a:extLst xmlns:a="http://schemas.openxmlformats.org/drawingml/2006/main">
               <a:ext uri="{FF2B5EF4-FFF2-40B4-BE49-F238E27FC236}">
-                <a16:creationId xmlns:a16="http://schemas.microsoft.com/office/drawing/2014/main" id="{3B8C41EC-3814-4B94-9DE9-BFFB427B0C37}"/>
+                <a16:creationId xmlns:a16="http://schemas.microsoft.com/office/drawing/2014/main" id="{FC8BFCD9-F6A0-4859-A85D-F59026E5DF8E}"/>
               </a:ext>
             </a:extLst>
           </p:cNvPr>
@@ -21380,7 +21209,7 @@
           <p:cNvPr id="3" name="">
             <a:extLst xmlns:a="http://schemas.openxmlformats.org/drawingml/2006/main">
               <a:ext uri="{FF2B5EF4-FFF2-40B4-BE49-F238E27FC236}">
-                <a16:creationId xmlns:a16="http://schemas.microsoft.com/office/drawing/2014/main" id="{3D95F97C-7C70-4B63-95D2-FED131BFB690}"/>
+                <a16:creationId xmlns:a16="http://schemas.microsoft.com/office/drawing/2014/main" id="{5952C220-B1BA-431E-8A37-CFC7515EFA06}"/>
               </a:ext>
             </a:extLst>
           </p:cNvPr>
@@ -21507,7 +21336,7 @@
           <p:cNvPr id="4" name="">
             <a:extLst xmlns:a="http://schemas.openxmlformats.org/drawingml/2006/main">
               <a:ext uri="{FF2B5EF4-FFF2-40B4-BE49-F238E27FC236}">
-                <a16:creationId xmlns:a16="http://schemas.microsoft.com/office/drawing/2014/main" id="{024F1F2A-90A7-489B-B84A-A64F04F2CD40}"/>
+                <a16:creationId xmlns:a16="http://schemas.microsoft.com/office/drawing/2014/main" id="{D62C93B7-968E-442F-8FDC-918349C61A33}"/>
               </a:ext>
             </a:extLst>
           </p:cNvPr>
@@ -21579,7 +21408,7 @@
           <p:cNvPr id="5" name="">
             <a:extLst xmlns:a="http://schemas.openxmlformats.org/drawingml/2006/main">
               <a:ext uri="{FF2B5EF4-FFF2-40B4-BE49-F238E27FC236}">
-                <a16:creationId xmlns:a16="http://schemas.microsoft.com/office/drawing/2014/main" id="{82B6E4E7-30CC-4382-8395-5B36AE95CF86}"/>
+                <a16:creationId xmlns:a16="http://schemas.microsoft.com/office/drawing/2014/main" id="{8F8AF77A-866E-4D7D-B576-69E668DA7820}"/>
               </a:ext>
             </a:extLst>
           </p:cNvPr>
@@ -21704,7 +21533,7 @@
     </p:spTree>
     <p:extLst>
       <p:ext uri="{BB962C8B-B14F-4D97-AF65-F5344CB8AC3E}">
-        <p14:creationId xmlns:p14="http://schemas.microsoft.com/office/powerpoint/2010/main" val="2048121794"/>
+        <p14:creationId xmlns:p14="http://schemas.microsoft.com/office/powerpoint/2010/main" val="1798097329"/>
       </p:ext>
     </p:extLst>
   </p:cSld>
@@ -21735,7 +21564,7 @@
           <p:cNvPr id="9" name="">
             <a:extLst xmlns:a="http://schemas.openxmlformats.org/drawingml/2006/main">
               <a:ext uri="{FF2B5EF4-FFF2-40B4-BE49-F238E27FC236}">
-                <a16:creationId xmlns:a16="http://schemas.microsoft.com/office/drawing/2014/main" id="{C01F039B-B641-45CD-B7FD-98C9871EC653}"/>
+                <a16:creationId xmlns:a16="http://schemas.microsoft.com/office/drawing/2014/main" id="{49232B1A-B7F3-4274-8845-2380FE3E507F}"/>
               </a:ext>
             </a:extLst>
           </p:cNvPr>
@@ -21807,7 +21636,7 @@
           <p:cNvPr id="2" name="">
             <a:extLst xmlns:a="http://schemas.openxmlformats.org/drawingml/2006/main">
               <a:ext uri="{FF2B5EF4-FFF2-40B4-BE49-F238E27FC236}">
-                <a16:creationId xmlns:a16="http://schemas.microsoft.com/office/drawing/2014/main" id="{4F859207-808D-4675-9A7E-A3A837D6FFAF}"/>
+                <a16:creationId xmlns:a16="http://schemas.microsoft.com/office/drawing/2014/main" id="{7C7C322D-EEFC-483C-992F-376843A8761D}"/>
               </a:ext>
             </a:extLst>
           </p:cNvPr>
@@ -21879,7 +21708,7 @@
           <p:cNvPr id="3" name="">
             <a:extLst xmlns:a="http://schemas.openxmlformats.org/drawingml/2006/main">
               <a:ext uri="{FF2B5EF4-FFF2-40B4-BE49-F238E27FC236}">
-                <a16:creationId xmlns:a16="http://schemas.microsoft.com/office/drawing/2014/main" id="{51BD4CFB-C41A-4793-9CA8-AC617CB3341E}"/>
+                <a16:creationId xmlns:a16="http://schemas.microsoft.com/office/drawing/2014/main" id="{E83ECB2B-7558-43F8-BFB1-A365E91A1889}"/>
               </a:ext>
             </a:extLst>
           </p:cNvPr>
@@ -21951,7 +21780,7 @@
           <p:cNvPr id="4" name="">
             <a:extLst xmlns:a="http://schemas.openxmlformats.org/drawingml/2006/main">
               <a:ext uri="{FF2B5EF4-FFF2-40B4-BE49-F238E27FC236}">
-                <a16:creationId xmlns:a16="http://schemas.microsoft.com/office/drawing/2014/main" id="{BC8DA5A9-53A0-4C18-AB5F-8A49D6DDDAD2}"/>
+                <a16:creationId xmlns:a16="http://schemas.microsoft.com/office/drawing/2014/main" id="{C351C461-45FA-4802-A952-B48C1F5CB5A5}"/>
               </a:ext>
             </a:extLst>
           </p:cNvPr>
@@ -22023,7 +21852,7 @@
           <p:cNvPr id="5" name="Chart">
             <a:extLst xmlns:a="http://schemas.openxmlformats.org/drawingml/2006/main">
               <a:ext uri="{FF2B5EF4-FFF2-40B4-BE49-F238E27FC236}">
-                <a16:creationId xmlns:a16="http://schemas.microsoft.com/office/drawing/2014/main" id="{6313460E-8D48-47A4-8F93-2D82182C86B0}"/>
+                <a16:creationId xmlns:a16="http://schemas.microsoft.com/office/drawing/2014/main" id="{E3FD6730-59E8-4315-9783-A6D3DCB1BD38}"/>
               </a:ext>
             </a:extLst>
           </p:cNvPr>
@@ -22036,7 +21865,7 @@
         </p:xfrm>
         <a:graphic xmlns:a="http://schemas.openxmlformats.org/drawingml/2006/main">
           <a:graphicData uri="http://schemas.openxmlformats.org/drawingml/2006/chart">
-            <c:chart xmlns:r="http://schemas.openxmlformats.org/officeDocument/2006/relationships" xmlns:c="http://schemas.openxmlformats.org/drawingml/2006/chart" r:id="Ref2270c0164b46bf"/>
+            <c:chart xmlns:r="http://schemas.openxmlformats.org/officeDocument/2006/relationships" xmlns:c="http://schemas.openxmlformats.org/drawingml/2006/chart" r:id="Rdaa4123c875f4ce4"/>
           </a:graphicData>
         </a:graphic>
       </p:graphicFrame>
@@ -22045,7 +21874,7 @@
           <p:cNvPr id="6" name="Chart">
             <a:extLst xmlns:a="http://schemas.openxmlformats.org/drawingml/2006/main">
               <a:ext uri="{FF2B5EF4-FFF2-40B4-BE49-F238E27FC236}">
-                <a16:creationId xmlns:a16="http://schemas.microsoft.com/office/drawing/2014/main" id="{4A19AEAD-F664-49AF-8639-D8295B9ED7AC}"/>
+                <a16:creationId xmlns:a16="http://schemas.microsoft.com/office/drawing/2014/main" id="{1924382F-8B62-4D74-A902-AAA5F53BA80B}"/>
               </a:ext>
             </a:extLst>
           </p:cNvPr>
@@ -22058,7 +21887,7 @@
         </p:xfrm>
         <a:graphic xmlns:a="http://schemas.openxmlformats.org/drawingml/2006/main">
           <a:graphicData uri="http://schemas.openxmlformats.org/drawingml/2006/chart">
-            <c:chart xmlns:r="http://schemas.openxmlformats.org/officeDocument/2006/relationships" xmlns:c="http://schemas.openxmlformats.org/drawingml/2006/chart" r:id="Rbe803f1a8bec49b2"/>
+            <c:chart xmlns:r="http://schemas.openxmlformats.org/officeDocument/2006/relationships" xmlns:c="http://schemas.openxmlformats.org/drawingml/2006/chart" r:id="R971965e9e5234fde"/>
           </a:graphicData>
         </a:graphic>
       </p:graphicFrame>
@@ -22067,7 +21896,7 @@
           <p:cNvPr id="7" name="">
             <a:extLst xmlns:a="http://schemas.openxmlformats.org/drawingml/2006/main">
               <a:ext uri="{FF2B5EF4-FFF2-40B4-BE49-F238E27FC236}">
-                <a16:creationId xmlns:a16="http://schemas.microsoft.com/office/drawing/2014/main" id="{19B63B5B-EDB7-4B5C-9120-B6A43940B79B}"/>
+                <a16:creationId xmlns:a16="http://schemas.microsoft.com/office/drawing/2014/main" id="{48E7687E-55A7-415C-BD1C-58EE1476EC2A}"/>
               </a:ext>
             </a:extLst>
           </p:cNvPr>
@@ -22203,7 +22032,7 @@
           <p:cNvPr id="8" name="">
             <a:extLst xmlns:a="http://schemas.openxmlformats.org/drawingml/2006/main">
               <a:ext uri="{FF2B5EF4-FFF2-40B4-BE49-F238E27FC236}">
-                <a16:creationId xmlns:a16="http://schemas.microsoft.com/office/drawing/2014/main" id="{905DD8BC-6AA6-4E94-8F6D-1A6535212877}"/>
+                <a16:creationId xmlns:a16="http://schemas.microsoft.com/office/drawing/2014/main" id="{08C32EC9-9663-43D6-BC4C-14FDFF8C75D1}"/>
               </a:ext>
             </a:extLst>
           </p:cNvPr>
@@ -22337,7 +22166,7 @@
     </p:spTree>
     <p:extLst>
       <p:ext uri="{BB962C8B-B14F-4D97-AF65-F5344CB8AC3E}">
-        <p14:creationId xmlns:p14="http://schemas.microsoft.com/office/powerpoint/2010/main" val="1566232592"/>
+        <p14:creationId xmlns:p14="http://schemas.microsoft.com/office/powerpoint/2010/main" val="1361145866"/>
       </p:ext>
     </p:extLst>
   </p:cSld>

</xml_diff>